<commit_message>
Update CM 2 and 1
</commit_message>
<xml_diff>
--- a/cours/FY26 CM2 Initiation au développement WEB 0.0.1.pptx
+++ b/cours/FY26 CM2 Initiation au développement WEB 0.0.1.pptx
@@ -234,27 +234,6 @@
 </p:cmAuthorLst>
 </file>
 
-<file path=ppt/comments/modernComment_7FFFD157_2C50AF3B.xml><?xml version="1.0" encoding="utf-8"?>
-<p188:cmLst xmlns:a="http://schemas.openxmlformats.org/drawingml/2006/main" xmlns:r="http://schemas.openxmlformats.org/officeDocument/2006/relationships" xmlns:p188="http://schemas.microsoft.com/office/powerpoint/2018/8/main">
-  <p188:cm id="{E5EAFBF7-6E26-453A-B475-79F98AB1495B}" authorId="{B6AA62E7-CC63-D207-C8E9-81F12E0F8FB2}" created="2026-03-27T12:32:45.402">
-    <pc:sldMkLst xmlns:pc="http://schemas.microsoft.com/office/powerpoint/2013/main/command">
-      <pc:docMk/>
-      <pc:sldMk cId="743485243" sldId="2147471703"/>
-    </pc:sldMkLst>
-    <p188:txBody>
-      <a:bodyPr/>
-      <a:lstStyle/>
-      <a:p>
-        <a:r>
-          <a:rPr lang="fr-FR"/>
-          <a:t>Ajouter de l’intéraction   </a:t>
-        </a:r>
-      </a:p>
-    </p188:txBody>
-  </p188:cm>
-</p188:cmLst>
-</file>
-
 <file path=ppt/comments/modernComment_7FFFD1E7_7B7465CA.xml><?xml version="1.0" encoding="utf-8"?>
 <p188:cmLst xmlns:a="http://schemas.openxmlformats.org/drawingml/2006/main" xmlns:r="http://schemas.openxmlformats.org/officeDocument/2006/relationships" xmlns:p188="http://schemas.microsoft.com/office/powerpoint/2018/8/main">
   <p188:cm id="{6A59DE6A-C59E-43E1-8F3A-6C945C9E7B83}" authorId="{B6AA62E7-CC63-D207-C8E9-81F12E0F8FB2}" created="2026-03-27T07:40:06.073">
@@ -433,7 +412,7 @@
               <a:rPr lang="en-CA" smtClean="0">
                 <a:latin typeface="Arial" pitchFamily="34" charset="0"/>
               </a:rPr>
-              <a:t>2026-04-03</a:t>
+              <a:t>2026-05-11</a:t>
             </a:fld>
             <a:endParaRPr lang="en-CA">
               <a:latin typeface="Arial" pitchFamily="34" charset="0"/>
@@ -611,7 +590,7 @@
           <a:p>
             <a:fld id="{B5D7A87D-1CDA-443F-BAE3-82C9C05446C3}" type="datetimeFigureOut">
               <a:rPr lang="en-CA" smtClean="0"/>
-              <a:t>2026-04-03</a:t>
+              <a:t>2026-05-11</a:t>
             </a:fld>
             <a:endParaRPr lang="en-CA"/>
           </a:p>
@@ -1378,6 +1357,19 @@
             </a:r>
           </a:p>
           <a:p>
+            <a:pPr marL="742950" lvl="1" indent="-285750">
+              <a:lnSpc>
+                <a:spcPct val="150000"/>
+              </a:lnSpc>
+              <a:buFont typeface="Arial" panose="020B0604020202020204" pitchFamily="34" charset="0"/>
+              <a:buChar char="•"/>
+            </a:pPr>
+            <a:r>
+              <a:rPr lang="fr-FR" sz="1200" noProof="0" dirty="0"/>
+              <a:t>Exemple Aéroport (stats contrôles EES, stats contrôles de Visa)</a:t>
+            </a:r>
+          </a:p>
+          <a:p>
             <a:pPr marL="285750" indent="-285750">
               <a:lnSpc>
                 <a:spcPct val="150000"/>
@@ -1547,15 +1539,94 @@
             </a:pPr>
             <a:r>
               <a:rPr lang="fr-FR" sz="1200" noProof="0" dirty="0"/>
-              <a:t>On peut retrouver d’autres nom mais l’idée reste la même.</a:t>
-            </a:r>
-          </a:p>
-          <a:p>
-            <a:pPr marL="0" indent="0" defTabSz="990752">
+              <a:t>On peut retrouver d’autres niveaux ou noms selon les outils mais l’idée reste la même.</a:t>
+            </a:r>
+          </a:p>
+          <a:p>
+            <a:pPr marL="0" marR="0" lvl="0" indent="0" algn="l" defTabSz="990752" rtl="0" eaLnBrk="1" fontAlgn="auto" latinLnBrk="0" hangingPunct="1">
+              <a:lnSpc>
+                <a:spcPct val="100000"/>
+              </a:lnSpc>
+              <a:spcBef>
+                <a:spcPts val="0"/>
+              </a:spcBef>
+              <a:spcAft>
+                <a:spcPts val="0"/>
+              </a:spcAft>
+              <a:buClrTx/>
+              <a:buSzTx/>
               <a:buFont typeface="Calibri"/>
               <a:buNone/>
+              <a:tabLst/>
               <a:defRPr/>
             </a:pPr>
+            <a:endParaRPr lang="fr-FR" sz="1200" noProof="0" dirty="0"/>
+          </a:p>
+          <a:p>
+            <a:pPr marL="0" marR="0" lvl="0" indent="0" algn="l" defTabSz="990752" rtl="0" eaLnBrk="1" fontAlgn="auto" latinLnBrk="0" hangingPunct="1">
+              <a:lnSpc>
+                <a:spcPct val="100000"/>
+              </a:lnSpc>
+              <a:spcBef>
+                <a:spcPts val="0"/>
+              </a:spcBef>
+              <a:spcAft>
+                <a:spcPts val="0"/>
+              </a:spcAft>
+              <a:buClrTx/>
+              <a:buSzTx/>
+              <a:buFont typeface="Calibri"/>
+              <a:buNone/>
+              <a:tabLst/>
+              <a:defRPr/>
+            </a:pPr>
+            <a:r>
+              <a:rPr lang="fr-FR" sz="1200" noProof="0" dirty="0"/>
+              <a:t>INFO = niveau par défaut (on affiche donc INFO et ce qui est au dessus)</a:t>
+            </a:r>
+          </a:p>
+          <a:p>
+            <a:pPr marL="0" marR="0" lvl="0" indent="0" algn="l" defTabSz="990752" rtl="0" eaLnBrk="1" fontAlgn="auto" latinLnBrk="0" hangingPunct="1">
+              <a:lnSpc>
+                <a:spcPct val="100000"/>
+              </a:lnSpc>
+              <a:spcBef>
+                <a:spcPts val="0"/>
+              </a:spcBef>
+              <a:spcAft>
+                <a:spcPts val="0"/>
+              </a:spcAft>
+              <a:buClrTx/>
+              <a:buSzTx/>
+              <a:buFont typeface="Calibri"/>
+              <a:buNone/>
+              <a:tabLst/>
+              <a:defRPr/>
+            </a:pPr>
+            <a:endParaRPr lang="fr-FR" sz="1200" noProof="0" dirty="0"/>
+          </a:p>
+          <a:p>
+            <a:pPr marL="0" marR="0" lvl="0" indent="0" algn="l" defTabSz="990752" rtl="0" eaLnBrk="1" fontAlgn="auto" latinLnBrk="0" hangingPunct="1">
+              <a:lnSpc>
+                <a:spcPct val="100000"/>
+              </a:lnSpc>
+              <a:spcBef>
+                <a:spcPts val="0"/>
+              </a:spcBef>
+              <a:spcAft>
+                <a:spcPts val="0"/>
+              </a:spcAft>
+              <a:buClrTx/>
+              <a:buSzTx/>
+              <a:buFont typeface="Calibri"/>
+              <a:buNone/>
+              <a:tabLst/>
+              <a:defRPr/>
+            </a:pPr>
+            <a:r>
+              <a:rPr lang="fr-FR" sz="1200" noProof="0" dirty="0"/>
+              <a:t>Permet de filtrer les niveaux lors des investigations.</a:t>
+            </a:r>
             <a:endParaRPr lang="fr-FR" dirty="0"/>
           </a:p>
         </p:txBody>
@@ -3096,7 +3167,26 @@
               <a:buNone/>
               <a:defRPr/>
             </a:pPr>
-            <a:endParaRPr lang="fr-FR" dirty="0"/>
+            <a:r>
+              <a:rPr lang="fr-FR" dirty="0"/>
+              <a:t>Notion </a:t>
+            </a:r>
+            <a:r>
+              <a:rPr lang="fr-FR" dirty="0" err="1"/>
+              <a:t>Checked</a:t>
+            </a:r>
+            <a:r>
+              <a:rPr lang="fr-FR" dirty="0"/>
+              <a:t> et </a:t>
+            </a:r>
+            <a:r>
+              <a:rPr lang="fr-FR" dirty="0" err="1"/>
+              <a:t>Unchecked</a:t>
+            </a:r>
+            <a:r>
+              <a:rPr lang="fr-FR" dirty="0"/>
+              <a:t> exception</a:t>
+            </a:r>
           </a:p>
         </p:txBody>
       </p:sp>
@@ -6766,6 +6856,14 @@
               <a:buNone/>
               <a:defRPr/>
             </a:pPr>
+            <a:r>
+              <a:rPr lang="fr-FR" dirty="0"/>
+              <a:t>Exemple intégration d’une API SOAP / </a:t>
+            </a:r>
+            <a:r>
+              <a:rPr lang="fr-FR" dirty="0" err="1"/>
+              <a:t>gRPC</a:t>
+            </a:r>
             <a:endParaRPr lang="fr-FR" dirty="0"/>
           </a:p>
         </p:txBody>
@@ -33225,7 +33323,7 @@
           </p:nvPr>
         </p:nvPicPr>
         <p:blipFill>
-          <a:blip r:embed="rId4">
+          <a:blip r:embed="rId3">
             <a:extLst>
               <a:ext uri="{28A0092B-C50C-407E-A947-70E740481C1C}">
                 <a14:useLocalDpi xmlns:a14="http://schemas.microsoft.com/office/drawing/2010/main" val="0"/>
@@ -33312,231 +33410,6 @@
           </a:p>
         </p:txBody>
       </p:sp>
-      <p:sp>
-        <p:nvSpPr>
-          <p:cNvPr id="12" name="Brand tip" descr="Note regarding updating the slide image.  To update this graphic device image, delete the current image and then click on the Image icon to change to a new picture located on your computer. &#10;Additional graphic device images are available in the image library of Brand Source at https://brand.cgi.com/ (filter graphic device).  &#10;Remove this note prior to distribution. ">
-            <a:extLst>
-              <a:ext uri="{FF2B5EF4-FFF2-40B4-BE49-F238E27FC236}">
-                <a16:creationId xmlns:a16="http://schemas.microsoft.com/office/drawing/2014/main" id="{2F7A3D0A-131E-F004-D1A3-37D009C3A8CC}"/>
-              </a:ext>
-              <a:ext uri="{C183D7F6-B498-43B3-948B-1728B52AA6E4}">
-                <adec:decorative xmlns:adec="http://schemas.microsoft.com/office/drawing/2017/decorative" val="0"/>
-              </a:ext>
-            </a:extLst>
-          </p:cNvPr>
-          <p:cNvSpPr txBox="1"/>
-          <p:nvPr/>
-        </p:nvSpPr>
-        <p:spPr bwMode="auto">
-          <a:xfrm>
-            <a:off x="12399902" y="0"/>
-            <a:ext cx="2190741" cy="1492716"/>
-          </a:xfrm>
-          <a:prstGeom prst="rect">
-            <a:avLst/>
-          </a:prstGeom>
-          <a:solidFill>
-            <a:srgbClr val="FFFFCC"/>
-          </a:solidFill>
-          <a:ln w="12700" algn="ctr">
-            <a:solidFill>
-              <a:schemeClr val="bg1">
-                <a:lumMod val="75000"/>
-              </a:schemeClr>
-            </a:solidFill>
-            <a:miter lim="800000"/>
-          </a:ln>
-          <a:effectLst/>
-        </p:spPr>
-        <p:txBody>
-          <a:bodyPr wrap="square" lIns="91440" tIns="45720" rIns="91440" bIns="45720" rtlCol="0">
-            <a:spAutoFit/>
-          </a:bodyPr>
-          <a:lstStyle/>
-          <a:p>
-            <a:pPr>
-              <a:spcAft>
-                <a:spcPts val="600"/>
-              </a:spcAft>
-            </a:pPr>
-            <a:r>
-              <a:rPr lang="fr-FR" sz="1400" b="1" noProof="0" dirty="0">
-                <a:solidFill>
-                  <a:schemeClr val="accent4"/>
-                </a:solidFill>
-                <a:cs typeface="Arial" pitchFamily="34" charset="0"/>
-              </a:rPr>
-              <a:t>Brand tip</a:t>
-            </a:r>
-          </a:p>
-          <a:p>
-            <a:pPr>
-              <a:spcAft>
-                <a:spcPts val="600"/>
-              </a:spcAft>
-            </a:pPr>
-            <a:r>
-              <a:rPr lang="fr-FR" sz="1200" noProof="0" dirty="0">
-                <a:cs typeface="Arial" pitchFamily="34" charset="0"/>
-              </a:rPr>
-              <a:t>Replace </a:t>
-            </a:r>
-            <a:r>
-              <a:rPr lang="fr-FR" sz="1200" noProof="0" dirty="0" err="1">
-                <a:cs typeface="Arial" pitchFamily="34" charset="0"/>
-              </a:rPr>
-              <a:t>this</a:t>
-            </a:r>
-            <a:r>
-              <a:rPr lang="fr-FR" sz="1200" noProof="0" dirty="0">
-                <a:cs typeface="Arial" pitchFamily="34" charset="0"/>
-              </a:rPr>
-              <a:t> image </a:t>
-            </a:r>
-            <a:r>
-              <a:rPr lang="fr-FR" sz="1200" noProof="0" dirty="0" err="1">
-                <a:cs typeface="Arial" pitchFamily="34" charset="0"/>
-              </a:rPr>
-              <a:t>with</a:t>
-            </a:r>
-            <a:r>
-              <a:rPr lang="fr-FR" sz="1200" noProof="0" dirty="0">
-                <a:cs typeface="Arial" pitchFamily="34" charset="0"/>
-              </a:rPr>
-              <a:t> an </a:t>
-            </a:r>
-            <a:r>
-              <a:rPr lang="fr-FR" sz="1200" b="1" noProof="0" dirty="0">
-                <a:cs typeface="Arial" pitchFamily="34" charset="0"/>
-              </a:rPr>
-              <a:t>original image</a:t>
-            </a:r>
-            <a:r>
-              <a:rPr lang="fr-FR" sz="1200" noProof="0" dirty="0">
-                <a:cs typeface="Arial" pitchFamily="34" charset="0"/>
-              </a:rPr>
-              <a:t> </a:t>
-            </a:r>
-            <a:r>
-              <a:rPr lang="fr-FR" sz="1200" noProof="0" dirty="0" err="1">
-                <a:cs typeface="Arial" pitchFamily="34" charset="0"/>
-              </a:rPr>
-              <a:t>from</a:t>
-            </a:r>
-            <a:r>
-              <a:rPr lang="fr-FR" sz="1200" noProof="0" dirty="0">
-                <a:cs typeface="Arial" pitchFamily="34" charset="0"/>
-              </a:rPr>
-              <a:t> the </a:t>
-            </a:r>
-            <a:r>
-              <a:rPr lang="fr-FR" sz="1200" b="1" noProof="0" dirty="0">
-                <a:solidFill>
-                  <a:schemeClr val="accent4"/>
-                </a:solidFill>
-                <a:cs typeface="Arial" pitchFamily="34" charset="0"/>
-                <a:hlinkClick r:id="rId5"/>
-              </a:rPr>
-              <a:t>image </a:t>
-            </a:r>
-            <a:r>
-              <a:rPr lang="fr-FR" sz="1200" b="1" noProof="0" dirty="0" err="1">
-                <a:solidFill>
-                  <a:schemeClr val="accent4"/>
-                </a:solidFill>
-                <a:cs typeface="Arial" pitchFamily="34" charset="0"/>
-                <a:hlinkClick r:id="rId5"/>
-              </a:rPr>
-              <a:t>library</a:t>
-            </a:r>
-            <a:r>
-              <a:rPr lang="fr-FR" sz="1200" noProof="0" dirty="0">
-                <a:cs typeface="Arial" pitchFamily="34" charset="0"/>
-              </a:rPr>
-              <a:t>.</a:t>
-            </a:r>
-            <a:br>
-              <a:rPr lang="fr-FR" sz="1200" b="1" noProof="0" dirty="0">
-                <a:solidFill>
-                  <a:schemeClr val="accent4"/>
-                </a:solidFill>
-                <a:cs typeface="Arial" pitchFamily="34" charset="0"/>
-              </a:rPr>
-            </a:br>
-            <a:br>
-              <a:rPr lang="fr-FR" sz="1200" b="1" noProof="0" dirty="0">
-                <a:solidFill>
-                  <a:schemeClr val="accent4"/>
-                </a:solidFill>
-                <a:cs typeface="Arial" pitchFamily="34" charset="0"/>
-              </a:rPr>
-            </a:br>
-            <a:r>
-              <a:rPr lang="fr-FR" sz="1200" b="1" noProof="0" dirty="0">
-                <a:solidFill>
-                  <a:schemeClr val="accent4"/>
-                </a:solidFill>
-                <a:cs typeface="Arial" pitchFamily="34" charset="0"/>
-              </a:rPr>
-              <a:t>DO NOT </a:t>
-            </a:r>
-            <a:r>
-              <a:rPr lang="fr-FR" sz="1200" b="1" noProof="0" dirty="0">
-                <a:cs typeface="Arial" pitchFamily="34" charset="0"/>
-              </a:rPr>
-              <a:t>use a </a:t>
-            </a:r>
-            <a:r>
-              <a:rPr lang="fr-FR" sz="1200" b="1" noProof="0" dirty="0" err="1">
-                <a:cs typeface="Arial" pitchFamily="34" charset="0"/>
-              </a:rPr>
-              <a:t>cornerstone</a:t>
-            </a:r>
-            <a:r>
-              <a:rPr lang="fr-FR" sz="1200" b="1" noProof="0" dirty="0">
-                <a:cs typeface="Arial" pitchFamily="34" charset="0"/>
-              </a:rPr>
-              <a:t> image </a:t>
-            </a:r>
-            <a:r>
-              <a:rPr lang="fr-FR" sz="1200" b="1" noProof="0" dirty="0" err="1">
-                <a:cs typeface="Arial" pitchFamily="34" charset="0"/>
-              </a:rPr>
-              <a:t>with</a:t>
-            </a:r>
-            <a:r>
-              <a:rPr lang="fr-FR" sz="1200" b="1" noProof="0" dirty="0">
-                <a:cs typeface="Arial" pitchFamily="34" charset="0"/>
-              </a:rPr>
-              <a:t> </a:t>
-            </a:r>
-            <a:r>
-              <a:rPr lang="fr-FR" sz="1200" b="1" noProof="0" dirty="0" err="1">
-                <a:cs typeface="Arial" pitchFamily="34" charset="0"/>
-              </a:rPr>
-              <a:t>this</a:t>
-            </a:r>
-            <a:r>
-              <a:rPr lang="fr-FR" sz="1200" b="1" noProof="0" dirty="0">
-                <a:cs typeface="Arial" pitchFamily="34" charset="0"/>
-              </a:rPr>
-              <a:t> </a:t>
-            </a:r>
-            <a:r>
-              <a:rPr lang="fr-FR" sz="1200" b="1" noProof="0" dirty="0" err="1">
-                <a:cs typeface="Arial" pitchFamily="34" charset="0"/>
-              </a:rPr>
-              <a:t>layout</a:t>
-            </a:r>
-            <a:r>
-              <a:rPr lang="fr-FR" sz="1200" b="1" noProof="0" dirty="0">
-                <a:cs typeface="Arial" pitchFamily="34" charset="0"/>
-              </a:rPr>
-              <a:t>.</a:t>
-            </a:r>
-          </a:p>
-        </p:txBody>
-      </p:sp>
       <p:pic>
         <p:nvPicPr>
           <p:cNvPr id="17" name="CGI logo" descr="CGI Inc. logo">
@@ -33552,7 +33425,7 @@
           <p:nvPr/>
         </p:nvPicPr>
         <p:blipFill>
-          <a:blip r:embed="rId6" cstate="screen">
+          <a:blip r:embed="rId4" cstate="screen">
             <a:extLst>
               <a:ext uri="{28A0092B-C50C-407E-A947-70E740481C1C}">
                 <a14:useLocalDpi xmlns:a14="http://schemas.microsoft.com/office/drawing/2010/main"/>
@@ -33627,11 +33500,6 @@
       </p:transition>
     </mc:Fallback>
   </mc:AlternateContent>
-  <p:extLst>
-    <p:ext uri="{6950BFC3-D8DA-4A85-94F7-54DA5524770B}">
-      <p188:commentRel xmlns:p188="http://schemas.microsoft.com/office/powerpoint/2018/8/main" r:id="rId3"/>
-    </p:ext>
-  </p:extLst>
 </p:sld>
 </file>
 
@@ -34911,7 +34779,7 @@
         <p:spPr>
           <a:xfrm>
             <a:off x="765737" y="1440763"/>
-            <a:ext cx="9096375" cy="4663264"/>
+            <a:ext cx="10133321" cy="4663264"/>
           </a:xfrm>
           <a:prstGeom prst="rect">
             <a:avLst/>
@@ -35000,7 +34868,7 @@
             </a:r>
             <a:r>
               <a:rPr lang="fr-FR" sz="1400" dirty="0"/>
-              <a:t> : Service de création des étudiants indisponible, bascule en mode dégradé</a:t>
+              <a:t> : Service de création des étudiants indisponible, bascule en mode dégradé qui permet une création partielle</a:t>
             </a:r>
           </a:p>
           <a:p>
@@ -37446,13 +37314,13 @@
   <p:clrMapOvr>
     <a:masterClrMapping/>
   </p:clrMapOvr>
-  <mc:AlternateContent xmlns:mc="http://schemas.openxmlformats.org/markup-compatibility/2006">
-    <mc:Choice xmlns:p14="http://schemas.microsoft.com/office/powerpoint/2010/main" Requires="p14">
+  <mc:AlternateContent xmlns:mc="http://schemas.openxmlformats.org/markup-compatibility/2006" xmlns:p14="http://schemas.microsoft.com/office/powerpoint/2010/main">
+    <mc:Choice Requires="p14">
       <p:transition spd="med" p14:dur="700">
         <p:fade/>
       </p:transition>
     </mc:Choice>
-    <mc:Fallback>
+    <mc:Fallback xmlns="">
       <p:transition spd="med">
         <p:fade/>
       </p:transition>
@@ -42937,7 +42805,7 @@
         <p:spPr>
           <a:xfrm>
             <a:off x="1091413" y="1472239"/>
-            <a:ext cx="4413592" cy="2037545"/>
+            <a:ext cx="4413592" cy="2262671"/>
           </a:xfrm>
           <a:prstGeom prst="rect">
             <a:avLst/>
@@ -42969,7 +42837,7 @@
               <a:buChar char="•"/>
             </a:pPr>
             <a:r>
-              <a:rPr lang="fr-FR" sz="1400" dirty="0"/>
+              <a:rPr lang="fr-FR" sz="1600" dirty="0"/>
               <a:t>Bugs fréquents</a:t>
             </a:r>
           </a:p>
@@ -42982,7 +42850,7 @@
               <a:buChar char="•"/>
             </a:pPr>
             <a:r>
-              <a:rPr lang="fr-FR" sz="1400" dirty="0"/>
+              <a:rPr lang="fr-FR" sz="1600" dirty="0"/>
               <a:t>Maintenance coûteuse</a:t>
             </a:r>
           </a:p>
@@ -42995,7 +42863,7 @@
               <a:buChar char="•"/>
             </a:pPr>
             <a:r>
-              <a:rPr lang="fr-FR" sz="1400" dirty="0"/>
+              <a:rPr lang="fr-FR" sz="1600" dirty="0"/>
               <a:t>Temps de développement élevé</a:t>
             </a:r>
           </a:p>
@@ -43008,7 +42876,7 @@
               <a:buChar char="•"/>
             </a:pPr>
             <a:r>
-              <a:rPr lang="fr-FR" sz="1400" dirty="0"/>
+              <a:rPr lang="fr-FR" sz="1600" dirty="0"/>
               <a:t>Forte dette technique</a:t>
             </a:r>
           </a:p>
@@ -43021,7 +42889,7 @@
               <a:buChar char="•"/>
             </a:pPr>
             <a:r>
-              <a:rPr lang="fr-FR" sz="1400" dirty="0"/>
+              <a:rPr lang="fr-FR" sz="1600" dirty="0"/>
               <a:t>Difficulté à travailler en équipe</a:t>
             </a:r>
           </a:p>
@@ -44703,13 +44571,13 @@
   <p:clrMapOvr>
     <a:masterClrMapping/>
   </p:clrMapOvr>
-  <mc:AlternateContent xmlns:mc="http://schemas.openxmlformats.org/markup-compatibility/2006">
-    <mc:Choice xmlns:p14="http://schemas.microsoft.com/office/powerpoint/2010/main" Requires="p14">
+  <mc:AlternateContent xmlns:mc="http://schemas.openxmlformats.org/markup-compatibility/2006" xmlns:p14="http://schemas.microsoft.com/office/powerpoint/2010/main">
+    <mc:Choice Requires="p14">
       <p:transition spd="med" p14:dur="700">
         <p:fade/>
       </p:transition>
     </mc:Choice>
-    <mc:Fallback>
+    <mc:Fallback xmlns="">
       <p:transition spd="med">
         <p:fade/>
       </p:transition>
@@ -46177,13 +46045,13 @@
   <p:clrMapOvr>
     <a:masterClrMapping/>
   </p:clrMapOvr>
-  <mc:AlternateContent xmlns:mc="http://schemas.openxmlformats.org/markup-compatibility/2006">
-    <mc:Choice xmlns:p14="http://schemas.microsoft.com/office/powerpoint/2010/main" Requires="p14">
+  <mc:AlternateContent xmlns:mc="http://schemas.openxmlformats.org/markup-compatibility/2006" xmlns:p14="http://schemas.microsoft.com/office/powerpoint/2010/main">
+    <mc:Choice Requires="p14">
       <p:transition spd="med" p14:dur="700">
         <p:fade/>
       </p:transition>
     </mc:Choice>
-    <mc:Fallback>
+    <mc:Fallback xmlns="">
       <p:transition spd="med">
         <p:fade/>
       </p:transition>
@@ -46560,13 +46428,13 @@
   <p:clrMapOvr>
     <a:masterClrMapping/>
   </p:clrMapOvr>
-  <mc:AlternateContent xmlns:mc="http://schemas.openxmlformats.org/markup-compatibility/2006">
-    <mc:Choice xmlns:p14="http://schemas.microsoft.com/office/powerpoint/2010/main" Requires="p14">
+  <mc:AlternateContent xmlns:mc="http://schemas.openxmlformats.org/markup-compatibility/2006" xmlns:p14="http://schemas.microsoft.com/office/powerpoint/2010/main">
+    <mc:Choice Requires="p14">
       <p:transition spd="med" p14:dur="700">
         <p:fade/>
       </p:transition>
     </mc:Choice>
-    <mc:Fallback>
+    <mc:Fallback xmlns="">
       <p:transition spd="med">
         <p:fade/>
       </p:transition>
@@ -46849,13 +46717,13 @@
   <p:clrMapOvr>
     <a:masterClrMapping/>
   </p:clrMapOvr>
-  <mc:AlternateContent xmlns:mc="http://schemas.openxmlformats.org/markup-compatibility/2006">
-    <mc:Choice xmlns:p14="http://schemas.microsoft.com/office/powerpoint/2010/main" Requires="p14">
+  <mc:AlternateContent xmlns:mc="http://schemas.openxmlformats.org/markup-compatibility/2006" xmlns:p14="http://schemas.microsoft.com/office/powerpoint/2010/main">
+    <mc:Choice Requires="p14">
       <p:transition spd="med" p14:dur="700">
         <p:fade/>
       </p:transition>
     </mc:Choice>
-    <mc:Fallback>
+    <mc:Fallback xmlns="">
       <p:transition spd="med">
         <p:fade/>
       </p:transition>
@@ -47771,13 +47639,13 @@
   <p:clrMapOvr>
     <a:masterClrMapping/>
   </p:clrMapOvr>
-  <mc:AlternateContent xmlns:mc="http://schemas.openxmlformats.org/markup-compatibility/2006">
-    <mc:Choice xmlns:p14="http://schemas.microsoft.com/office/powerpoint/2010/main" Requires="p14">
+  <mc:AlternateContent xmlns:mc="http://schemas.openxmlformats.org/markup-compatibility/2006" xmlns:p14="http://schemas.microsoft.com/office/powerpoint/2010/main">
+    <mc:Choice Requires="p14">
       <p:transition spd="med" p14:dur="700">
         <p:fade/>
       </p:transition>
     </mc:Choice>
-    <mc:Fallback>
+    <mc:Fallback xmlns="">
       <p:transition spd="med">
         <p:fade/>
       </p:transition>
@@ -48511,13 +48379,13 @@
   <p:clrMapOvr>
     <a:masterClrMapping/>
   </p:clrMapOvr>
-  <mc:AlternateContent xmlns:mc="http://schemas.openxmlformats.org/markup-compatibility/2006">
-    <mc:Choice xmlns:p14="http://schemas.microsoft.com/office/powerpoint/2010/main" Requires="p14">
+  <mc:AlternateContent xmlns:mc="http://schemas.openxmlformats.org/markup-compatibility/2006" xmlns:p14="http://schemas.microsoft.com/office/powerpoint/2010/main">
+    <mc:Choice Requires="p14">
       <p:transition spd="med" p14:dur="700">
         <p:fade/>
       </p:transition>
     </mc:Choice>
-    <mc:Fallback>
+    <mc:Fallback xmlns="">
       <p:transition spd="med">
         <p:fade/>
       </p:transition>
@@ -48887,13 +48755,13 @@
   <p:clrMapOvr>
     <a:masterClrMapping/>
   </p:clrMapOvr>
-  <mc:AlternateContent xmlns:mc="http://schemas.openxmlformats.org/markup-compatibility/2006">
-    <mc:Choice xmlns:p14="http://schemas.microsoft.com/office/powerpoint/2010/main" Requires="p14">
+  <mc:AlternateContent xmlns:mc="http://schemas.openxmlformats.org/markup-compatibility/2006" xmlns:p14="http://schemas.microsoft.com/office/powerpoint/2010/main">
+    <mc:Choice Requires="p14">
       <p:transition spd="med" p14:dur="700">
         <p:fade/>
       </p:transition>
     </mc:Choice>
-    <mc:Fallback>
+    <mc:Fallback xmlns="">
       <p:transition spd="med">
         <p:fade/>
       </p:transition>
@@ -49236,13 +49104,13 @@
   <p:clrMapOvr>
     <a:masterClrMapping/>
   </p:clrMapOvr>
-  <mc:AlternateContent xmlns:mc="http://schemas.openxmlformats.org/markup-compatibility/2006">
-    <mc:Choice xmlns:p14="http://schemas.microsoft.com/office/powerpoint/2010/main" Requires="p14">
+  <mc:AlternateContent xmlns:mc="http://schemas.openxmlformats.org/markup-compatibility/2006" xmlns:p14="http://schemas.microsoft.com/office/powerpoint/2010/main">
+    <mc:Choice Requires="p14">
       <p:transition spd="med" p14:dur="700">
         <p:fade/>
       </p:transition>
     </mc:Choice>
-    <mc:Fallback>
+    <mc:Fallback xmlns="">
       <p:transition spd="med">
         <p:fade/>
       </p:transition>
@@ -49601,7 +49469,7 @@
 </file>
 
 <file path=ppt/slides/slide43.xml><?xml version="1.0" encoding="utf-8"?>
-<p:sld xmlns:a="http://schemas.openxmlformats.org/drawingml/2006/main" xmlns:r="http://schemas.openxmlformats.org/officeDocument/2006/relationships" xmlns:p="http://schemas.openxmlformats.org/presentationml/2006/main" show="0">
+<p:sld xmlns:a="http://schemas.openxmlformats.org/drawingml/2006/main" xmlns:r="http://schemas.openxmlformats.org/officeDocument/2006/relationships" xmlns:p="http://schemas.openxmlformats.org/presentationml/2006/main">
   <p:cSld>
     <p:spTree>
       <p:nvGrpSpPr>
@@ -49716,7 +49584,7 @@
 </file>
 
 <file path=ppt/slides/slide44.xml><?xml version="1.0" encoding="utf-8"?>
-<p:sld xmlns:a="http://schemas.openxmlformats.org/drawingml/2006/main" xmlns:r="http://schemas.openxmlformats.org/officeDocument/2006/relationships" xmlns:p="http://schemas.openxmlformats.org/presentationml/2006/main" show="0">
+<p:sld xmlns:a="http://schemas.openxmlformats.org/drawingml/2006/main" xmlns:r="http://schemas.openxmlformats.org/officeDocument/2006/relationships" xmlns:p="http://schemas.openxmlformats.org/presentationml/2006/main">
   <p:cSld>
     <p:spTree>
       <p:nvGrpSpPr>
@@ -49985,7 +49853,7 @@
 </file>
 
 <file path=ppt/slides/slide45.xml><?xml version="1.0" encoding="utf-8"?>
-<p:sld xmlns:a="http://schemas.openxmlformats.org/drawingml/2006/main" xmlns:r="http://schemas.openxmlformats.org/officeDocument/2006/relationships" xmlns:p="http://schemas.openxmlformats.org/presentationml/2006/main" show="0">
+<p:sld xmlns:a="http://schemas.openxmlformats.org/drawingml/2006/main" xmlns:r="http://schemas.openxmlformats.org/officeDocument/2006/relationships" xmlns:p="http://schemas.openxmlformats.org/presentationml/2006/main">
   <p:cSld>
     <p:spTree>
       <p:nvGrpSpPr>
@@ -50522,7 +50390,7 @@
 </file>
 
 <file path=ppt/slides/slide46.xml><?xml version="1.0" encoding="utf-8"?>
-<p:sld xmlns:a="http://schemas.openxmlformats.org/drawingml/2006/main" xmlns:r="http://schemas.openxmlformats.org/officeDocument/2006/relationships" xmlns:p="http://schemas.openxmlformats.org/presentationml/2006/main" show="0">
+<p:sld xmlns:a="http://schemas.openxmlformats.org/drawingml/2006/main" xmlns:r="http://schemas.openxmlformats.org/officeDocument/2006/relationships" xmlns:p="http://schemas.openxmlformats.org/presentationml/2006/main">
   <p:cSld>
     <p:spTree>
       <p:nvGrpSpPr>
@@ -50984,13 +50852,13 @@
   <p:clrMapOvr>
     <a:masterClrMapping/>
   </p:clrMapOvr>
-  <mc:AlternateContent xmlns:mc="http://schemas.openxmlformats.org/markup-compatibility/2006">
-    <mc:Choice xmlns:p14="http://schemas.microsoft.com/office/powerpoint/2010/main" Requires="p14">
+  <mc:AlternateContent xmlns:mc="http://schemas.openxmlformats.org/markup-compatibility/2006" xmlns:p14="http://schemas.microsoft.com/office/powerpoint/2010/main">
+    <mc:Choice Requires="p14">
       <p:transition spd="med" p14:dur="700">
         <p:fade/>
       </p:transition>
     </mc:Choice>
-    <mc:Fallback>
+    <mc:Fallback xmlns="">
       <p:transition spd="med">
         <p:fade/>
       </p:transition>
@@ -51231,7 +51099,7 @@
             </a:pPr>
             <a:r>
               <a:rPr lang="fr-FR" sz="1400" u="sng" dirty="0"/>
-              <a:t>Meilleur maintenabilité</a:t>
+              <a:t>Meilleure maintenabilité</a:t>
             </a:r>
           </a:p>
           <a:p>
@@ -51587,7 +51455,7 @@
         </p:nvSpPr>
         <p:spPr>
           <a:xfrm>
-            <a:off x="765737" y="1708265"/>
+            <a:off x="778094" y="1708265"/>
             <a:ext cx="10210799" cy="5293757"/>
           </a:xfrm>
           <a:prstGeom prst="rect">
@@ -54221,67 +54089,6 @@
 </file>
 
 <file path=customXml/item1.xml><?xml version="1.0" encoding="utf-8"?>
-<?mso-contentType ?>
-<p:Policy xmlns:p="office.server.policy" id="" local="true">
-  <p:Name>Dossier Administratif Info Policy</p:Name>
-  <p:Description>Dossier Administratif Info Policy</p:Description>
-  <p:Statement>Dossier Administratif Info Policy</p:Statement>
-  <p:PolicyItems>
-    <p:PolicyItem featureId="Microsoft.Office.RecordsManagement.PolicyFeatures.PolicyLabel" staticId="0x0101009A52C5AAAFC23349B8BDB1B4A6E5BBA100BE7DAB2C58B328489915C63B8D980AC0|801092262" UniqueId="c9fe96b4-252f-4cd4-b06b-87f80ac09546">
-      <p:Name>Labels</p:Name>
-      <p:Description>Generates labels that can be inserted in Microsoft Office documents to ensure that document properties or other important information are included when documents are printed. Labels can also be used to search for documents.</p:Description>
-      <p:CustomData>
-        <label>
-          <segment type="metadata">_UIVersionString</segment>
-        </label>
-      </p:CustomData>
-    </p:PolicyItem>
-  </p:PolicyItems>
-</p:Policy>
-</file>
-
-<file path=customXml/item2.xml><?xml version="1.0" encoding="utf-8"?>
-<?mso-contentType ?>
-<SharedContentType xmlns="Microsoft.SharePoint.Taxonomy.ContentTypeSync" SourceId="204c783a-96cf-4a0f-a0fc-232f03230527" ContentTypeId="0x0101009A52C5AAAFC23349B8BDB1B4A6E5BBA1" PreviousValue="false"/>
-</file>
-
-<file path=customXml/item3.xml><?xml version="1.0" encoding="utf-8"?>
-<?mso-contentType ?>
-<FormTemplates xmlns="http://schemas.microsoft.com/sharepoint/v3/contenttype/forms">
-  <Display>DocumentLibraryForm</Display>
-  <Edit>DocumentLibraryForm</Edit>
-  <New>DocumentLibraryForm</New>
-</FormTemplates>
-</file>
-
-<file path=customXml/item4.xml><?xml version="1.0" encoding="utf-8"?>
-<p:properties xmlns:p="http://schemas.microsoft.com/office/2006/metadata/properties" xmlns:xsi="http://www.w3.org/2001/XMLSchema-instance">
-  <documentManagement>
-    <DocCTLanguage xmlns="1467fb8b-7944-4202-8e80-6a5cf0d18287">Anglais</DocCTLanguage>
-    <TaxKeywordTaxHTField xmlns="1467fb8b-7944-4202-8e80-6a5cf0d18287">
-      <Terms xmlns="http://schemas.microsoft.com/office/infopath/2007/PartnerControls"/>
-    </TaxKeywordTaxHTField>
-    <DocumentAudience xmlns="1467fb8b-7944-4202-8e80-6a5cf0d18287">CGI seulement</DocumentAudience>
-    <Classification xmlns="1467fb8b-7944-4202-8e80-6a5cf0d18287">Interne</Classification>
-    <AdministrativeFileTopic xmlns="1467fb8b-7944-4202-8e80-6a5cf0d18287">N/A</AdministrativeFileTopic>
-    <d03104a6d34b444fb9971a4d8e41064a xmlns="1467fb8b-7944-4202-8e80-6a5cf0d18287">
-      <Terms xmlns="http://schemas.microsoft.com/office/infopath/2007/PartnerControls"/>
-    </d03104a6d34b444fb9971a4d8e41064a>
-    <TaxCatchAll xmlns="1467fb8b-7944-4202-8e80-6a5cf0d18287"/>
-    <AuthorEnsemble xmlns="1467fb8b-7944-4202-8e80-6a5cf0d18287" xsi:nil="true"/>
-    <PublishedDate xmlns="http://schemas.microsoft.com/sharepoint/v3" xsi:nil="true"/>
-    <AdministrativeFileDocumentType xmlns="1467fb8b-7944-4202-8e80-6a5cf0d18287">Documentation</AdministrativeFileDocumentType>
-    <ChangeRequestID xmlns="1467fb8b-7944-4202-8e80-6a5cf0d18287" xsi:nil="true"/>
-    <TaxCatchAllLabel xmlns="1467fb8b-7944-4202-8e80-6a5cf0d18287"/>
-    <_dlc_Exempt xmlns="http://schemas.microsoft.com/sharepoint/v3" xsi:nil="true"/>
-    <DLCPolicyLabelClientValue xmlns="22d87773-e74c-4cbb-84cc-45cb2e9e9a01" xsi:nil="true"/>
-    <DLCPolicyLabelLock xmlns="22d87773-e74c-4cbb-84cc-45cb2e9e9a01" xsi:nil="true"/>
-    <DLCPolicyLabelValue xmlns="22d87773-e74c-4cbb-84cc-45cb2e9e9a01">0.1</DLCPolicyLabelValue>
-  </documentManagement>
-</p:properties>
-</file>
-
-<file path=customXml/item5.xml><?xml version="1.0" encoding="utf-8"?>
 <ct:contentTypeSchema xmlns:ct="http://schemas.microsoft.com/office/2006/metadata/contentType" xmlns:ma="http://schemas.microsoft.com/office/2006/metadata/properties/metaAttributes" ct:_="" ma:_="" ma:contentTypeName="Dossier Administratif" ma:contentTypeID="0x0101009A52C5AAAFC23349B8BDB1B4A6E5BBA100BE7DAB2C58B328489915C63B8D980AC0" ma:contentTypeVersion="11" ma:contentTypeDescription="Crée un document." ma:contentTypeScope="" ma:versionID="7bbb76030f15e2b896280439ed7c7543">
   <xsd:schema xmlns:xsd="http://www.w3.org/2001/XMLSchema" xmlns:xs="http://www.w3.org/2001/XMLSchema" xmlns:p="http://schemas.microsoft.com/office/2006/metadata/properties" xmlns:ns1="http://schemas.microsoft.com/sharepoint/v3" xmlns:ns2="1467fb8b-7944-4202-8e80-6a5cf0d18287" xmlns:ns3="22d87773-e74c-4cbb-84cc-45cb2e9e9a01" targetNamespace="http://schemas.microsoft.com/office/2006/metadata/properties" ma:root="true" ma:fieldsID="35a237271d09c8f7fda9c2c1fcd6a1b2" ns1:_="" ns2:_="" ns3:_="">
     <xsd:import namespace="http://schemas.microsoft.com/sharepoint/v3"/>
@@ -54559,49 +54366,68 @@
 </ct:contentTypeSchema>
 </file>
 
-<file path=customXml/itemProps1.xml><?xml version="1.0" encoding="utf-8"?>
-<ds:datastoreItem xmlns:ds="http://schemas.openxmlformats.org/officeDocument/2006/customXml" ds:itemID="{9AAC4EDA-821D-42CA-898C-BF5EBD2F1030}">
-  <ds:schemaRefs>
-    <ds:schemaRef ds:uri="office.server.policy"/>
-  </ds:schemaRefs>
-</ds:datastoreItem>
+<file path=customXml/item2.xml><?xml version="1.0" encoding="utf-8"?>
+<p:properties xmlns:p="http://schemas.microsoft.com/office/2006/metadata/properties" xmlns:xsi="http://www.w3.org/2001/XMLSchema-instance">
+  <documentManagement>
+    <DocCTLanguage xmlns="1467fb8b-7944-4202-8e80-6a5cf0d18287">Anglais</DocCTLanguage>
+    <TaxKeywordTaxHTField xmlns="1467fb8b-7944-4202-8e80-6a5cf0d18287">
+      <Terms xmlns="http://schemas.microsoft.com/office/infopath/2007/PartnerControls"/>
+    </TaxKeywordTaxHTField>
+    <DocumentAudience xmlns="1467fb8b-7944-4202-8e80-6a5cf0d18287">CGI seulement</DocumentAudience>
+    <Classification xmlns="1467fb8b-7944-4202-8e80-6a5cf0d18287">Interne</Classification>
+    <AdministrativeFileTopic xmlns="1467fb8b-7944-4202-8e80-6a5cf0d18287">N/A</AdministrativeFileTopic>
+    <d03104a6d34b444fb9971a4d8e41064a xmlns="1467fb8b-7944-4202-8e80-6a5cf0d18287">
+      <Terms xmlns="http://schemas.microsoft.com/office/infopath/2007/PartnerControls"/>
+    </d03104a6d34b444fb9971a4d8e41064a>
+    <TaxCatchAll xmlns="1467fb8b-7944-4202-8e80-6a5cf0d18287"/>
+    <AuthorEnsemble xmlns="1467fb8b-7944-4202-8e80-6a5cf0d18287" xsi:nil="true"/>
+    <PublishedDate xmlns="http://schemas.microsoft.com/sharepoint/v3" xsi:nil="true"/>
+    <AdministrativeFileDocumentType xmlns="1467fb8b-7944-4202-8e80-6a5cf0d18287">Documentation</AdministrativeFileDocumentType>
+    <ChangeRequestID xmlns="1467fb8b-7944-4202-8e80-6a5cf0d18287" xsi:nil="true"/>
+    <TaxCatchAllLabel xmlns="1467fb8b-7944-4202-8e80-6a5cf0d18287"/>
+    <_dlc_Exempt xmlns="http://schemas.microsoft.com/sharepoint/v3" xsi:nil="true"/>
+    <DLCPolicyLabelClientValue xmlns="22d87773-e74c-4cbb-84cc-45cb2e9e9a01" xsi:nil="true"/>
+    <DLCPolicyLabelLock xmlns="22d87773-e74c-4cbb-84cc-45cb2e9e9a01" xsi:nil="true"/>
+    <DLCPolicyLabelValue xmlns="22d87773-e74c-4cbb-84cc-45cb2e9e9a01">0.1</DLCPolicyLabelValue>
+  </documentManagement>
+</p:properties>
 </file>
 
-<file path=customXml/itemProps2.xml><?xml version="1.0" encoding="utf-8"?>
-<ds:datastoreItem xmlns:ds="http://schemas.openxmlformats.org/officeDocument/2006/customXml" ds:itemID="{957F5D7A-96FD-4145-BBEE-1CFD1405758E}">
-  <ds:schemaRefs>
-    <ds:schemaRef ds:uri="Microsoft.SharePoint.Taxonomy.ContentTypeSync"/>
-  </ds:schemaRefs>
-</ds:datastoreItem>
+<file path=customXml/item3.xml><?xml version="1.0" encoding="utf-8"?>
+<?mso-contentType ?>
+<FormTemplates xmlns="http://schemas.microsoft.com/sharepoint/v3/contenttype/forms">
+  <Display>DocumentLibraryForm</Display>
+  <Edit>DocumentLibraryForm</Edit>
+  <New>DocumentLibraryForm</New>
+</FormTemplates>
 </file>
 
-<file path=customXml/itemProps3.xml><?xml version="1.0" encoding="utf-8"?>
-<ds:datastoreItem xmlns:ds="http://schemas.openxmlformats.org/officeDocument/2006/customXml" ds:itemID="{ADA5D674-9920-4D2F-B065-BC24FD29F86D}">
-  <ds:schemaRefs>
-    <ds:schemaRef ds:uri="http://schemas.microsoft.com/sharepoint/v3/contenttype/forms"/>
-  </ds:schemaRefs>
-</ds:datastoreItem>
+<file path=customXml/item4.xml><?xml version="1.0" encoding="utf-8"?>
+<?mso-contentType ?>
+<SharedContentType xmlns="Microsoft.SharePoint.Taxonomy.ContentTypeSync" SourceId="204c783a-96cf-4a0f-a0fc-232f03230527" ContentTypeId="0x0101009A52C5AAAFC23349B8BDB1B4A6E5BBA1" PreviousValue="false"/>
 </file>
 
-<file path=customXml/itemProps4.xml><?xml version="1.0" encoding="utf-8"?>
-<ds:datastoreItem xmlns:ds="http://schemas.openxmlformats.org/officeDocument/2006/customXml" ds:itemID="{2F4C4F6A-F6A5-45C8-BAAA-52FB70E387C7}">
-  <ds:schemaRefs>
-    <ds:schemaRef ds:uri="1467fb8b-7944-4202-8e80-6a5cf0d18287"/>
-    <ds:schemaRef ds:uri="http://purl.org/dc/terms/"/>
-    <ds:schemaRef ds:uri="http://schemas.microsoft.com/office/2006/metadata/properties"/>
-    <ds:schemaRef ds:uri="http://schemas.microsoft.com/office/2006/documentManagement/types"/>
-    <ds:schemaRef ds:uri="http://purl.org/dc/dcmitype/"/>
-    <ds:schemaRef ds:uri="http://purl.org/dc/elements/1.1/"/>
-    <ds:schemaRef ds:uri="http://schemas.microsoft.com/office/infopath/2007/PartnerControls"/>
-    <ds:schemaRef ds:uri="http://schemas.openxmlformats.org/package/2006/metadata/core-properties"/>
-    <ds:schemaRef ds:uri="22d87773-e74c-4cbb-84cc-45cb2e9e9a01"/>
-    <ds:schemaRef ds:uri="http://schemas.microsoft.com/sharepoint/v3"/>
-    <ds:schemaRef ds:uri="http://www.w3.org/XML/1998/namespace"/>
-  </ds:schemaRefs>
-</ds:datastoreItem>
+<file path=customXml/item5.xml><?xml version="1.0" encoding="utf-8"?>
+<?mso-contentType ?>
+<p:Policy xmlns:p="office.server.policy" id="" local="true">
+  <p:Name>Dossier Administratif Info Policy</p:Name>
+  <p:Description>Dossier Administratif Info Policy</p:Description>
+  <p:Statement>Dossier Administratif Info Policy</p:Statement>
+  <p:PolicyItems>
+    <p:PolicyItem featureId="Microsoft.Office.RecordsManagement.PolicyFeatures.PolicyLabel" staticId="0x0101009A52C5AAAFC23349B8BDB1B4A6E5BBA100BE7DAB2C58B328489915C63B8D980AC0|801092262" UniqueId="c9fe96b4-252f-4cd4-b06b-87f80ac09546">
+      <p:Name>Labels</p:Name>
+      <p:Description>Generates labels that can be inserted in Microsoft Office documents to ensure that document properties or other important information are included when documents are printed. Labels can also be used to search for documents.</p:Description>
+      <p:CustomData>
+        <label>
+          <segment type="metadata">_UIVersionString</segment>
+        </label>
+      </p:CustomData>
+    </p:PolicyItem>
+  </p:PolicyItems>
+</p:Policy>
 </file>
 
-<file path=customXml/itemProps5.xml><?xml version="1.0" encoding="utf-8"?>
+<file path=customXml/itemProps1.xml><?xml version="1.0" encoding="utf-8"?>
 <ds:datastoreItem xmlns:ds="http://schemas.openxmlformats.org/officeDocument/2006/customXml" ds:itemID="{07578963-F6A3-4D9B-917F-D20BFBBF4949}">
   <ds:schemaRefs>
     <ds:schemaRef ds:uri="1467fb8b-7944-4202-8e80-6a5cf0d18287"/>
@@ -54621,6 +54447,48 @@
 </ds:datastoreItem>
 </file>
 
+<file path=customXml/itemProps2.xml><?xml version="1.0" encoding="utf-8"?>
+<ds:datastoreItem xmlns:ds="http://schemas.openxmlformats.org/officeDocument/2006/customXml" ds:itemID="{2F4C4F6A-F6A5-45C8-BAAA-52FB70E387C7}">
+  <ds:schemaRefs>
+    <ds:schemaRef ds:uri="1467fb8b-7944-4202-8e80-6a5cf0d18287"/>
+    <ds:schemaRef ds:uri="http://purl.org/dc/terms/"/>
+    <ds:schemaRef ds:uri="http://schemas.microsoft.com/office/2006/metadata/properties"/>
+    <ds:schemaRef ds:uri="http://schemas.microsoft.com/office/2006/documentManagement/types"/>
+    <ds:schemaRef ds:uri="http://purl.org/dc/dcmitype/"/>
+    <ds:schemaRef ds:uri="http://purl.org/dc/elements/1.1/"/>
+    <ds:schemaRef ds:uri="http://schemas.microsoft.com/office/infopath/2007/PartnerControls"/>
+    <ds:schemaRef ds:uri="http://schemas.openxmlformats.org/package/2006/metadata/core-properties"/>
+    <ds:schemaRef ds:uri="22d87773-e74c-4cbb-84cc-45cb2e9e9a01"/>
+    <ds:schemaRef ds:uri="http://schemas.microsoft.com/sharepoint/v3"/>
+    <ds:schemaRef ds:uri="http://www.w3.org/XML/1998/namespace"/>
+  </ds:schemaRefs>
+</ds:datastoreItem>
+</file>
+
+<file path=customXml/itemProps3.xml><?xml version="1.0" encoding="utf-8"?>
+<ds:datastoreItem xmlns:ds="http://schemas.openxmlformats.org/officeDocument/2006/customXml" ds:itemID="{ADA5D674-9920-4D2F-B065-BC24FD29F86D}">
+  <ds:schemaRefs>
+    <ds:schemaRef ds:uri="http://schemas.microsoft.com/sharepoint/v3/contenttype/forms"/>
+  </ds:schemaRefs>
+</ds:datastoreItem>
+</file>
+
+<file path=customXml/itemProps4.xml><?xml version="1.0" encoding="utf-8"?>
+<ds:datastoreItem xmlns:ds="http://schemas.openxmlformats.org/officeDocument/2006/customXml" ds:itemID="{957F5D7A-96FD-4145-BBEE-1CFD1405758E}">
+  <ds:schemaRefs>
+    <ds:schemaRef ds:uri="Microsoft.SharePoint.Taxonomy.ContentTypeSync"/>
+  </ds:schemaRefs>
+</ds:datastoreItem>
+</file>
+
+<file path=customXml/itemProps5.xml><?xml version="1.0" encoding="utf-8"?>
+<ds:datastoreItem xmlns:ds="http://schemas.openxmlformats.org/officeDocument/2006/customXml" ds:itemID="{9AAC4EDA-821D-42CA-898C-BF5EBD2F1030}">
+  <ds:schemaRefs>
+    <ds:schemaRef ds:uri="office.server.policy"/>
+  </ds:schemaRefs>
+</ds:datastoreItem>
+</file>
+
 <file path=docMetadata/LabelInfo.xml><?xml version="1.0" encoding="utf-8"?>
 <clbl:labelList xmlns:clbl="http://schemas.microsoft.com/office/2020/mipLabelMetadata">
   <clbl:label id="{d9290083-bd2f-48a2-8ac5-09a524b17d15}" enabled="1" method="Privileged" siteId="{b9fec68c-c92d-461e-9a97-3d03a0f18b82}" contentBits="1" removed="0"/>

</xml_diff>